<commit_message>
pptx: add 3 new defense slides and fix critical bounds error
New slides added:
  - Slide 9:  Bid Exponent Sweep (alpha 1–3 + adaptive; parabolic optimum)
  - Slide 19: Live Web Simulator (searchfcr.fozhan.dev, QR, screenshot)
  - Slide 23: Anticipated Q&A Backup (4-block 2x2 grid)

Critical fix:
  - Slide 18 (Every bound holds): M4 bound corrected from 4.78 to 13.87;
    M2 bound 3.05->3.34; tightness ratios corrected for all four models;
    M1 row (18.74 < 34.09) added to table.

Also adds gen_slides.py and rebuild_pptx.py for reproducibility.

Co-Authored-By: Claude Sonnet 4.6 <noreply@anthropic.com>
</commit_message>
<xml_diff>
--- a/SearchFCR_Conference_Presentation.pptx
+++ b/SearchFCR_Conference_Presentation.pptx
@@ -13,6 +13,7 @@
     <p:sldId id="261" r:id="rId7"/>
     <p:sldId id="262" r:id="rId8"/>
     <p:sldId id="263" r:id="rId9"/>
+    <p:sldId id="276" r:id="rId27"/>
     <p:sldId id="264" r:id="rId10"/>
     <p:sldId id="265" r:id="rId11"/>
     <p:sldId id="266" r:id="rId12"/>
@@ -22,9 +23,11 @@
     <p:sldId id="270" r:id="rId16"/>
     <p:sldId id="271" r:id="rId17"/>
     <p:sldId id="272" r:id="rId18"/>
+    <p:sldId id="277" r:id="rId28"/>
     <p:sldId id="273" r:id="rId19"/>
     <p:sldId id="274" r:id="rId20"/>
     <p:sldId id="275" r:id="rId21"/>
+    <p:sldId id="278" r:id="rId29"/>
   </p:sldIdLst>
   <p:notesMasterIdLst>
     <p:notesMasterId r:id="rId22"/>
@@ -1616,6 +1619,51 @@
   <p:clrMapOvr>
     <a:masterClrMapping/>
   </p:clrMapOvr>
+</p:notes>
+</file>
+
+<file path=ppt/notesSlides/notesSlide21.xml><?xml version="1.0" encoding="utf-8"?>
+<p:notes xmlns:a="http://schemas.openxmlformats.org/drawingml/2006/main" xmlns:r="http://schemas.openxmlformats.org/officeDocument/2006/relationships" xmlns:p="http://schemas.openxmlformats.org/presentationml/2006/main">
+  <p:cSld>
+    <p:spTree>
+      <p:nvGrpSpPr>
+        <p:cNvPr id="1" name=""/>
+        <p:cNvGrpSpPr/>
+        <p:nvPr/>
+      </p:nvGrpSpPr>
+      <p:grpSpPr/>
+    </p:spTree>
+  </p:cSld>
+</p:notes>
+</file>
+
+<file path=ppt/notesSlides/notesSlide22.xml><?xml version="1.0" encoding="utf-8"?>
+<p:notes xmlns:a="http://schemas.openxmlformats.org/drawingml/2006/main" xmlns:r="http://schemas.openxmlformats.org/officeDocument/2006/relationships" xmlns:p="http://schemas.openxmlformats.org/presentationml/2006/main">
+  <p:cSld>
+    <p:spTree>
+      <p:nvGrpSpPr>
+        <p:cNvPr id="1" name=""/>
+        <p:cNvGrpSpPr/>
+        <p:nvPr/>
+      </p:nvGrpSpPr>
+      <p:grpSpPr/>
+    </p:spTree>
+  </p:cSld>
+</p:notes>
+</file>
+
+<file path=ppt/notesSlides/notesSlide23.xml><?xml version="1.0" encoding="utf-8"?>
+<p:notes xmlns:a="http://schemas.openxmlformats.org/drawingml/2006/main" xmlns:r="http://schemas.openxmlformats.org/officeDocument/2006/relationships" xmlns:p="http://schemas.openxmlformats.org/presentationml/2006/main">
+  <p:cSld>
+    <p:spTree>
+      <p:nvGrpSpPr>
+        <p:cNvPr id="1" name=""/>
+        <p:cNvGrpSpPr/>
+        <p:nvPr/>
+      </p:nvGrpSpPr>
+      <p:grpSpPr/>
+    </p:spTree>
+  </p:cSld>
 </p:notes>
 </file>
 
@@ -2561,7 +2609,7 @@
       </p:grpSpPr>
       <p:pic>
         <p:nvPicPr>
-          <p:cNvPr id="2" name="Image 0" descr="C:\Users\fooja\Documents\GitHub\Multi-Robot-Algo\slide_screenshots\slide_01.png">    </p:cNvPr>
+          <p:cNvPr id="2" name="Image 0" descr="C:\Users\fooja\Documents\GitHub\Multi-Robot-Algo\slide_screenshots\slide_01.png"/>
           <p:cNvPicPr>
             <a:picLocks noChangeAspect="1"/>
           </p:cNvPicPr>
@@ -2610,7 +2658,7 @@
       </p:grpSpPr>
       <p:pic>
         <p:nvPicPr>
-          <p:cNvPr id="2" name="Image 0" descr="C:\Users\fooja\Documents\GitHub\Multi-Robot-Algo\slide_screenshots\slide_10.png">    </p:cNvPr>
+          <p:cNvPr id="2" name="Image 0" descr="C:\Users\fooja\Documents\GitHub\Multi-Robot-Algo\slide_screenshots\slide_10.png"/>
           <p:cNvPicPr>
             <a:picLocks noChangeAspect="1"/>
           </p:cNvPicPr>
@@ -2659,7 +2707,7 @@
       </p:grpSpPr>
       <p:pic>
         <p:nvPicPr>
-          <p:cNvPr id="2" name="Image 0" descr="C:\Users\fooja\Documents\GitHub\Multi-Robot-Algo\slide_screenshots\slide_11.png">    </p:cNvPr>
+          <p:cNvPr id="2" name="Image 0" descr="C:\Users\fooja\Documents\GitHub\Multi-Robot-Algo\slide_screenshots\slide_11.png"/>
           <p:cNvPicPr>
             <a:picLocks noChangeAspect="1"/>
           </p:cNvPicPr>
@@ -2708,7 +2756,7 @@
       </p:grpSpPr>
       <p:pic>
         <p:nvPicPr>
-          <p:cNvPr id="2" name="Image 0" descr="C:\Users\fooja\Documents\GitHub\Multi-Robot-Algo\slide_screenshots\slide_12.png">    </p:cNvPr>
+          <p:cNvPr id="2" name="Image 0" descr="C:\Users\fooja\Documents\GitHub\Multi-Robot-Algo\slide_screenshots\slide_12.png"/>
           <p:cNvPicPr>
             <a:picLocks noChangeAspect="1"/>
           </p:cNvPicPr>
@@ -2757,7 +2805,7 @@
       </p:grpSpPr>
       <p:pic>
         <p:nvPicPr>
-          <p:cNvPr id="2" name="Image 0" descr="C:\Users\fooja\Documents\GitHub\Multi-Robot-Algo\slide_screenshots\slide_13.png">    </p:cNvPr>
+          <p:cNvPr id="2" name="Image 0" descr="C:\Users\fooja\Documents\GitHub\Multi-Robot-Algo\slide_screenshots\slide_13.png"/>
           <p:cNvPicPr>
             <a:picLocks noChangeAspect="1"/>
           </p:cNvPicPr>
@@ -2806,7 +2854,7 @@
       </p:grpSpPr>
       <p:pic>
         <p:nvPicPr>
-          <p:cNvPr id="2" name="Image 0" descr="C:\Users\fooja\Documents\GitHub\Multi-Robot-Algo\slide_screenshots\slide_14.png">    </p:cNvPr>
+          <p:cNvPr id="2" name="Image 0" descr="C:\Users\fooja\Documents\GitHub\Multi-Robot-Algo\slide_screenshots\slide_14.png"/>
           <p:cNvPicPr>
             <a:picLocks noChangeAspect="1"/>
           </p:cNvPicPr>
@@ -2855,7 +2903,7 @@
       </p:grpSpPr>
       <p:pic>
         <p:nvPicPr>
-          <p:cNvPr id="2" name="Image 0" descr="C:\Users\fooja\Documents\GitHub\Multi-Robot-Algo\slide_screenshots\slide_15.png">    </p:cNvPr>
+          <p:cNvPr id="2" name="Image 0" descr="C:\Users\fooja\Documents\GitHub\Multi-Robot-Algo\slide_screenshots\slide_15.png"/>
           <p:cNvPicPr>
             <a:picLocks noChangeAspect="1"/>
           </p:cNvPicPr>
@@ -2904,7 +2952,7 @@
       </p:grpSpPr>
       <p:pic>
         <p:nvPicPr>
-          <p:cNvPr id="2" name="Image 0" descr="C:\Users\fooja\Documents\GitHub\Multi-Robot-Algo\slide_screenshots\slide_16.png">    </p:cNvPr>
+          <p:cNvPr id="2" name="Image 0" descr="C:\Users\fooja\Documents\GitHub\Multi-Robot-Algo\slide_screenshots\slide_16.png"/>
           <p:cNvPicPr>
             <a:picLocks noChangeAspect="1"/>
           </p:cNvPicPr>
@@ -2953,7 +3001,7 @@
       </p:grpSpPr>
       <p:pic>
         <p:nvPicPr>
-          <p:cNvPr id="2" name="Image 0" descr="C:\Users\fooja\Documents\GitHub\Multi-Robot-Algo\slide_screenshots\slide_17.png">    </p:cNvPr>
+          <p:cNvPr id="2" name="Image 0" descr="C:\Users\fooja\Documents\GitHub\Multi-Robot-Algo\slide_screenshots\slide_17.png"/>
           <p:cNvPicPr>
             <a:picLocks noChangeAspect="1"/>
           </p:cNvPicPr>
@@ -3002,7 +3050,7 @@
       </p:grpSpPr>
       <p:pic>
         <p:nvPicPr>
-          <p:cNvPr id="2" name="Image 0" descr="C:\Users\fooja\Documents\GitHub\Multi-Robot-Algo\slide_screenshots\slide_18.png">    </p:cNvPr>
+          <p:cNvPr id="2" name="Image 0" descr="C:\Users\fooja\Documents\GitHub\Multi-Robot-Algo\slide_screenshots\slide_18.png"/>
           <p:cNvPicPr>
             <a:picLocks noChangeAspect="1"/>
           </p:cNvPicPr>
@@ -3051,7 +3099,7 @@
       </p:grpSpPr>
       <p:pic>
         <p:nvPicPr>
-          <p:cNvPr id="2" name="Image 0" descr="C:\Users\fooja\Documents\GitHub\Multi-Robot-Algo\slide_screenshots\slide_19.png">    </p:cNvPr>
+          <p:cNvPr id="2" name="Image 0" descr="C:\Users\fooja\Documents\GitHub\Multi-Robot-Algo\slide_screenshots\slide_19.png"/>
           <p:cNvPicPr>
             <a:picLocks noChangeAspect="1"/>
           </p:cNvPicPr>
@@ -3100,7 +3148,7 @@
       </p:grpSpPr>
       <p:pic>
         <p:nvPicPr>
-          <p:cNvPr id="2" name="Image 0" descr="C:\Users\fooja\Documents\GitHub\Multi-Robot-Algo\slide_screenshots\slide_02.png">    </p:cNvPr>
+          <p:cNvPr id="2" name="Image 0" descr="C:\Users\fooja\Documents\GitHub\Multi-Robot-Algo\slide_screenshots\slide_02.png"/>
           <p:cNvPicPr>
             <a:picLocks noChangeAspect="1"/>
           </p:cNvPicPr>
@@ -3149,7 +3197,7 @@
       </p:grpSpPr>
       <p:pic>
         <p:nvPicPr>
-          <p:cNvPr id="2" name="Image 0" descr="C:\Users\fooja\Documents\GitHub\Multi-Robot-Algo\slide_screenshots\slide_20.png">    </p:cNvPr>
+          <p:cNvPr id="2" name="Image 0" descr="C:\Users\fooja\Documents\GitHub\Multi-Robot-Algo\slide_screenshots\slide_20.png"/>
           <p:cNvPicPr>
             <a:picLocks noChangeAspect="1"/>
           </p:cNvPicPr>
@@ -3179,9 +3227,9 @@
 </p:sld>
 </file>
 
-<file path=ppt/slides/slide3.xml><?xml version="1.0" encoding="utf-8"?>
+<file path=ppt/slides/slide21.xml><?xml version="1.0" encoding="utf-8"?>
 <p:sld xmlns:a="http://schemas.openxmlformats.org/drawingml/2006/main" xmlns:r="http://schemas.openxmlformats.org/officeDocument/2006/relationships" xmlns:p="http://schemas.openxmlformats.org/presentationml/2006/main">
-  <p:cSld name="Slide 3">
+  <p:cSld name="Exponent Sweep">
     <p:spTree>
       <p:nvGrpSpPr>
         <p:cNvPr id="1" name=""/>
@@ -3198,7 +3246,7 @@
       </p:grpSpPr>
       <p:pic>
         <p:nvPicPr>
-          <p:cNvPr id="2" name="Image 0" descr="C:\Users\fooja\Documents\GitHub\Multi-Robot-Algo\slide_screenshots\slide_03.png">    </p:cNvPr>
+          <p:cNvPr id="2" name="Image 0" descr="image-21-1.png"/>
           <p:cNvPicPr>
             <a:picLocks noChangeAspect="1"/>
           </p:cNvPicPr>
@@ -3228,9 +3276,9 @@
 </p:sld>
 </file>
 
-<file path=ppt/slides/slide4.xml><?xml version="1.0" encoding="utf-8"?>
+<file path=ppt/slides/slide22.xml><?xml version="1.0" encoding="utf-8"?>
 <p:sld xmlns:a="http://schemas.openxmlformats.org/drawingml/2006/main" xmlns:r="http://schemas.openxmlformats.org/officeDocument/2006/relationships" xmlns:p="http://schemas.openxmlformats.org/presentationml/2006/main">
-  <p:cSld name="Slide 4">
+  <p:cSld name="Web Simulator">
     <p:spTree>
       <p:nvGrpSpPr>
         <p:cNvPr id="1" name=""/>
@@ -3247,7 +3295,7 @@
       </p:grpSpPr>
       <p:pic>
         <p:nvPicPr>
-          <p:cNvPr id="2" name="Image 0" descr="C:\Users\fooja\Documents\GitHub\Multi-Robot-Algo\slide_screenshots\slide_04.png">    </p:cNvPr>
+          <p:cNvPr id="2" name="Image 0" descr="image-22-1.png"/>
           <p:cNvPicPr>
             <a:picLocks noChangeAspect="1"/>
           </p:cNvPicPr>
@@ -3277,9 +3325,9 @@
 </p:sld>
 </file>
 
-<file path=ppt/slides/slide5.xml><?xml version="1.0" encoding="utf-8"?>
+<file path=ppt/slides/slide23.xml><?xml version="1.0" encoding="utf-8"?>
 <p:sld xmlns:a="http://schemas.openxmlformats.org/drawingml/2006/main" xmlns:r="http://schemas.openxmlformats.org/officeDocument/2006/relationships" xmlns:p="http://schemas.openxmlformats.org/presentationml/2006/main">
-  <p:cSld name="Slide 5">
+  <p:cSld name="Q&amp;A Backup">
     <p:spTree>
       <p:nvGrpSpPr>
         <p:cNvPr id="1" name=""/>
@@ -3296,7 +3344,7 @@
       </p:grpSpPr>
       <p:pic>
         <p:nvPicPr>
-          <p:cNvPr id="2" name="Image 0" descr="C:\Users\fooja\Documents\GitHub\Multi-Robot-Algo\slide_screenshots\slide_05.png">    </p:cNvPr>
+          <p:cNvPr id="2" name="Image 0" descr="image-23-1.png"/>
           <p:cNvPicPr>
             <a:picLocks noChangeAspect="1"/>
           </p:cNvPicPr>
@@ -3326,9 +3374,9 @@
 </p:sld>
 </file>
 
-<file path=ppt/slides/slide6.xml><?xml version="1.0" encoding="utf-8"?>
+<file path=ppt/slides/slide3.xml><?xml version="1.0" encoding="utf-8"?>
 <p:sld xmlns:a="http://schemas.openxmlformats.org/drawingml/2006/main" xmlns:r="http://schemas.openxmlformats.org/officeDocument/2006/relationships" xmlns:p="http://schemas.openxmlformats.org/presentationml/2006/main">
-  <p:cSld name="Slide 6">
+  <p:cSld name="Slide 3">
     <p:spTree>
       <p:nvGrpSpPr>
         <p:cNvPr id="1" name=""/>
@@ -3345,7 +3393,7 @@
       </p:grpSpPr>
       <p:pic>
         <p:nvPicPr>
-          <p:cNvPr id="2" name="Image 0" descr="C:\Users\fooja\Documents\GitHub\Multi-Robot-Algo\slide_screenshots\slide_06.png">    </p:cNvPr>
+          <p:cNvPr id="2" name="Image 0" descr="C:\Users\fooja\Documents\GitHub\Multi-Robot-Algo\slide_screenshots\slide_03.png"/>
           <p:cNvPicPr>
             <a:picLocks noChangeAspect="1"/>
           </p:cNvPicPr>
@@ -3375,9 +3423,9 @@
 </p:sld>
 </file>
 
-<file path=ppt/slides/slide7.xml><?xml version="1.0" encoding="utf-8"?>
+<file path=ppt/slides/slide4.xml><?xml version="1.0" encoding="utf-8"?>
 <p:sld xmlns:a="http://schemas.openxmlformats.org/drawingml/2006/main" xmlns:r="http://schemas.openxmlformats.org/officeDocument/2006/relationships" xmlns:p="http://schemas.openxmlformats.org/presentationml/2006/main">
-  <p:cSld name="Slide 7">
+  <p:cSld name="Slide 4">
     <p:spTree>
       <p:nvGrpSpPr>
         <p:cNvPr id="1" name=""/>
@@ -3394,7 +3442,7 @@
       </p:grpSpPr>
       <p:pic>
         <p:nvPicPr>
-          <p:cNvPr id="2" name="Image 0" descr="C:\Users\fooja\Documents\GitHub\Multi-Robot-Algo\slide_screenshots\slide_07.png">    </p:cNvPr>
+          <p:cNvPr id="2" name="Image 0" descr="C:\Users\fooja\Documents\GitHub\Multi-Robot-Algo\slide_screenshots\slide_04.png"/>
           <p:cNvPicPr>
             <a:picLocks noChangeAspect="1"/>
           </p:cNvPicPr>
@@ -3424,9 +3472,9 @@
 </p:sld>
 </file>
 
-<file path=ppt/slides/slide8.xml><?xml version="1.0" encoding="utf-8"?>
+<file path=ppt/slides/slide5.xml><?xml version="1.0" encoding="utf-8"?>
 <p:sld xmlns:a="http://schemas.openxmlformats.org/drawingml/2006/main" xmlns:r="http://schemas.openxmlformats.org/officeDocument/2006/relationships" xmlns:p="http://schemas.openxmlformats.org/presentationml/2006/main">
-  <p:cSld name="Slide 8">
+  <p:cSld name="Slide 5">
     <p:spTree>
       <p:nvGrpSpPr>
         <p:cNvPr id="1" name=""/>
@@ -3443,7 +3491,7 @@
       </p:grpSpPr>
       <p:pic>
         <p:nvPicPr>
-          <p:cNvPr id="2" name="Image 0" descr="C:\Users\fooja\Documents\GitHub\Multi-Robot-Algo\slide_screenshots\slide_08.png">    </p:cNvPr>
+          <p:cNvPr id="2" name="Image 0" descr="C:\Users\fooja\Documents\GitHub\Multi-Robot-Algo\slide_screenshots\slide_05.png"/>
           <p:cNvPicPr>
             <a:picLocks noChangeAspect="1"/>
           </p:cNvPicPr>
@@ -3473,6 +3521,153 @@
 </p:sld>
 </file>
 
+<file path=ppt/slides/slide6.xml><?xml version="1.0" encoding="utf-8"?>
+<p:sld xmlns:a="http://schemas.openxmlformats.org/drawingml/2006/main" xmlns:r="http://schemas.openxmlformats.org/officeDocument/2006/relationships" xmlns:p="http://schemas.openxmlformats.org/presentationml/2006/main">
+  <p:cSld name="Slide 6">
+    <p:spTree>
+      <p:nvGrpSpPr>
+        <p:cNvPr id="1" name=""/>
+        <p:cNvGrpSpPr/>
+        <p:nvPr/>
+      </p:nvGrpSpPr>
+      <p:grpSpPr>
+        <a:xfrm>
+          <a:off x="0" y="0"/>
+          <a:ext cx="0" cy="0"/>
+          <a:chOff x="0" y="0"/>
+          <a:chExt cx="0" cy="0"/>
+        </a:xfrm>
+      </p:grpSpPr>
+      <p:pic>
+        <p:nvPicPr>
+          <p:cNvPr id="2" name="Image 0" descr="C:\Users\fooja\Documents\GitHub\Multi-Robot-Algo\slide_screenshots\slide_06.png"/>
+          <p:cNvPicPr>
+            <a:picLocks noChangeAspect="1"/>
+          </p:cNvPicPr>
+          <p:nvPr/>
+        </p:nvPicPr>
+        <p:blipFill>
+          <a:blip r:embed="rId1"/>
+          <a:stretch>
+            <a:fillRect/>
+          </a:stretch>
+        </p:blipFill>
+        <p:spPr>
+          <a:xfrm>
+            <a:off x="0" y="0"/>
+            <a:ext cx="12192000" cy="6858000"/>
+          </a:xfrm>
+          <a:prstGeom prst="rect">
+            <a:avLst/>
+          </a:prstGeom>
+        </p:spPr>
+      </p:pic>
+    </p:spTree>
+  </p:cSld>
+  <p:clrMapOvr>
+    <a:masterClrMapping/>
+  </p:clrMapOvr>
+</p:sld>
+</file>
+
+<file path=ppt/slides/slide7.xml><?xml version="1.0" encoding="utf-8"?>
+<p:sld xmlns:a="http://schemas.openxmlformats.org/drawingml/2006/main" xmlns:r="http://schemas.openxmlformats.org/officeDocument/2006/relationships" xmlns:p="http://schemas.openxmlformats.org/presentationml/2006/main">
+  <p:cSld name="Slide 7">
+    <p:spTree>
+      <p:nvGrpSpPr>
+        <p:cNvPr id="1" name=""/>
+        <p:cNvGrpSpPr/>
+        <p:nvPr/>
+      </p:nvGrpSpPr>
+      <p:grpSpPr>
+        <a:xfrm>
+          <a:off x="0" y="0"/>
+          <a:ext cx="0" cy="0"/>
+          <a:chOff x="0" y="0"/>
+          <a:chExt cx="0" cy="0"/>
+        </a:xfrm>
+      </p:grpSpPr>
+      <p:pic>
+        <p:nvPicPr>
+          <p:cNvPr id="2" name="Image 0" descr="C:\Users\fooja\Documents\GitHub\Multi-Robot-Algo\slide_screenshots\slide_07.png"/>
+          <p:cNvPicPr>
+            <a:picLocks noChangeAspect="1"/>
+          </p:cNvPicPr>
+          <p:nvPr/>
+        </p:nvPicPr>
+        <p:blipFill>
+          <a:blip r:embed="rId1"/>
+          <a:stretch>
+            <a:fillRect/>
+          </a:stretch>
+        </p:blipFill>
+        <p:spPr>
+          <a:xfrm>
+            <a:off x="0" y="0"/>
+            <a:ext cx="12192000" cy="6858000"/>
+          </a:xfrm>
+          <a:prstGeom prst="rect">
+            <a:avLst/>
+          </a:prstGeom>
+        </p:spPr>
+      </p:pic>
+    </p:spTree>
+  </p:cSld>
+  <p:clrMapOvr>
+    <a:masterClrMapping/>
+  </p:clrMapOvr>
+</p:sld>
+</file>
+
+<file path=ppt/slides/slide8.xml><?xml version="1.0" encoding="utf-8"?>
+<p:sld xmlns:a="http://schemas.openxmlformats.org/drawingml/2006/main" xmlns:r="http://schemas.openxmlformats.org/officeDocument/2006/relationships" xmlns:p="http://schemas.openxmlformats.org/presentationml/2006/main">
+  <p:cSld name="Slide 8">
+    <p:spTree>
+      <p:nvGrpSpPr>
+        <p:cNvPr id="1" name=""/>
+        <p:cNvGrpSpPr/>
+        <p:nvPr/>
+      </p:nvGrpSpPr>
+      <p:grpSpPr>
+        <a:xfrm>
+          <a:off x="0" y="0"/>
+          <a:ext cx="0" cy="0"/>
+          <a:chOff x="0" y="0"/>
+          <a:chExt cx="0" cy="0"/>
+        </a:xfrm>
+      </p:grpSpPr>
+      <p:pic>
+        <p:nvPicPr>
+          <p:cNvPr id="2" name="Image 0" descr="C:\Users\fooja\Documents\GitHub\Multi-Robot-Algo\slide_screenshots\slide_08.png"/>
+          <p:cNvPicPr>
+            <a:picLocks noChangeAspect="1"/>
+          </p:cNvPicPr>
+          <p:nvPr/>
+        </p:nvPicPr>
+        <p:blipFill>
+          <a:blip r:embed="rId1"/>
+          <a:stretch>
+            <a:fillRect/>
+          </a:stretch>
+        </p:blipFill>
+        <p:spPr>
+          <a:xfrm>
+            <a:off x="0" y="0"/>
+            <a:ext cx="12192000" cy="6858000"/>
+          </a:xfrm>
+          <a:prstGeom prst="rect">
+            <a:avLst/>
+          </a:prstGeom>
+        </p:spPr>
+      </p:pic>
+    </p:spTree>
+  </p:cSld>
+  <p:clrMapOvr>
+    <a:masterClrMapping/>
+  </p:clrMapOvr>
+</p:sld>
+</file>
+
 <file path=ppt/slides/slide9.xml><?xml version="1.0" encoding="utf-8"?>
 <p:sld xmlns:a="http://schemas.openxmlformats.org/drawingml/2006/main" xmlns:r="http://schemas.openxmlformats.org/officeDocument/2006/relationships" xmlns:p="http://schemas.openxmlformats.org/presentationml/2006/main">
   <p:cSld name="Slide 9">
@@ -3492,7 +3687,7 @@
       </p:grpSpPr>
       <p:pic>
         <p:nvPicPr>
-          <p:cNvPr id="2" name="Image 0" descr="C:\Users\fooja\Documents\GitHub\Multi-Robot-Algo\slide_screenshots\slide_09.png">    </p:cNvPr>
+          <p:cNvPr id="2" name="Image 0" descr="C:\Users\fooja\Documents\GitHub\Multi-Robot-Algo\slide_screenshots\slide_09.png"/>
           <p:cNvPicPr>
             <a:picLocks noChangeAspect="1"/>
           </p:cNvPicPr>

</xml_diff>